<commit_message>
Deploying to gh-pages from  @ bf43bcceee74de824c1ecb08549530ddda03e316 🚀
</commit_message>
<xml_diff>
--- a/img/diagramms.pptx
+++ b/img/diagramms.pptx
@@ -2681,7 +2681,7 @@
             <a:prstDash val="dash"/>
             <a:round/>
             <a:headEnd type="none" w="med" len="med"/>
-            <a:tailEnd type="none" w="med" len="med"/>
+            <a:tailEnd type="arrow" w="med" len="med"/>
           </a:ln>
         </p:spPr>
         <p:style>
@@ -2699,53 +2699,6 @@
           </a:fontRef>
         </p:style>
       </p:cxnSp>
-      <p:cxnSp>
-        <p:nvCxnSpPr>
-          <p:cNvPr id="57" name="Straight Arrow Connector 56">
-            <a:extLst>
-              <a:ext uri="{FF2B5EF4-FFF2-40B4-BE49-F238E27FC236}">
-                <a16:creationId xmlns:a16="http://schemas.microsoft.com/office/drawing/2014/main" id="{00D4E27E-2F3C-703E-94F9-C449484F5F93}"/>
-              </a:ext>
-            </a:extLst>
-          </p:cNvPr>
-          <p:cNvCxnSpPr>
-            <a:endCxn id="41" idx="1"/>
-          </p:cNvCxnSpPr>
-          <p:nvPr/>
-        </p:nvCxnSpPr>
-        <p:spPr>
-          <a:xfrm>
-            <a:off x="8001000" y="5137803"/>
-            <a:ext cx="121516" cy="610"/>
-          </a:xfrm>
-          <a:prstGeom prst="straightConnector1">
-            <a:avLst/>
-          </a:prstGeom>
-          <a:ln w="9525" cap="flat" cmpd="sng" algn="ctr">
-            <a:solidFill>
-              <a:schemeClr val="dk1"/>
-            </a:solidFill>
-            <a:prstDash val="solid"/>
-            <a:round/>
-            <a:headEnd type="none" w="med" len="med"/>
-            <a:tailEnd type="arrow" w="med" len="med"/>
-          </a:ln>
-        </p:spPr>
-        <p:style>
-          <a:lnRef idx="0">
-            <a:scrgbClr r="0" g="0" b="0"/>
-          </a:lnRef>
-          <a:fillRef idx="0">
-            <a:scrgbClr r="0" g="0" b="0"/>
-          </a:fillRef>
-          <a:effectRef idx="0">
-            <a:scrgbClr r="0" g="0" b="0"/>
-          </a:effectRef>
-          <a:fontRef idx="minor">
-            <a:schemeClr val="tx1"/>
-          </a:fontRef>
-        </p:style>
-      </p:cxnSp>
       <p:sp>
         <p:nvSpPr>
           <p:cNvPr id="59" name="Shape 36">
@@ -2903,7 +2856,7 @@
             <a:prstDash val="dash"/>
             <a:round/>
             <a:headEnd type="none" w="med" len="med"/>
-            <a:tailEnd type="none" w="med" len="med"/>
+            <a:tailEnd type="arrow" w="med" len="med"/>
           </a:ln>
         </p:spPr>
         <p:style>
@@ -2952,7 +2905,7 @@
             <a:prstDash val="dash"/>
             <a:round/>
             <a:headEnd type="none" w="med" len="med"/>
-            <a:tailEnd type="none" w="med" len="med"/>
+            <a:tailEnd type="arrow" w="med" len="med"/>
           </a:ln>
         </p:spPr>
         <p:style>
@@ -2999,148 +2952,6 @@
               <a:schemeClr val="dk1"/>
             </a:solidFill>
             <a:prstDash val="dash"/>
-            <a:round/>
-            <a:headEnd type="none" w="med" len="med"/>
-            <a:tailEnd type="none" w="med" len="med"/>
-          </a:ln>
-        </p:spPr>
-        <p:style>
-          <a:lnRef idx="0">
-            <a:scrgbClr r="0" g="0" b="0"/>
-          </a:lnRef>
-          <a:fillRef idx="0">
-            <a:scrgbClr r="0" g="0" b="0"/>
-          </a:fillRef>
-          <a:effectRef idx="0">
-            <a:scrgbClr r="0" g="0" b="0"/>
-          </a:effectRef>
-          <a:fontRef idx="minor">
-            <a:schemeClr val="tx1"/>
-          </a:fontRef>
-        </p:style>
-      </p:cxnSp>
-      <p:cxnSp>
-        <p:nvCxnSpPr>
-          <p:cNvPr id="78" name="Straight Arrow Connector 77">
-            <a:extLst>
-              <a:ext uri="{FF2B5EF4-FFF2-40B4-BE49-F238E27FC236}">
-                <a16:creationId xmlns:a16="http://schemas.microsoft.com/office/drawing/2014/main" id="{7445AF9E-8CC6-9289-6492-BAF6C1933A50}"/>
-              </a:ext>
-            </a:extLst>
-          </p:cNvPr>
-          <p:cNvCxnSpPr>
-            <a:cxnSpLocks/>
-          </p:cNvCxnSpPr>
-          <p:nvPr/>
-        </p:nvCxnSpPr>
-        <p:spPr>
-          <a:xfrm>
-            <a:off x="6983718" y="6133220"/>
-            <a:ext cx="121516" cy="51612"/>
-          </a:xfrm>
-          <a:prstGeom prst="straightConnector1">
-            <a:avLst/>
-          </a:prstGeom>
-          <a:ln w="9525" cap="flat" cmpd="sng" algn="ctr">
-            <a:solidFill>
-              <a:schemeClr val="dk1"/>
-            </a:solidFill>
-            <a:prstDash val="solid"/>
-            <a:round/>
-            <a:headEnd type="none" w="med" len="med"/>
-            <a:tailEnd type="arrow" w="med" len="med"/>
-          </a:ln>
-        </p:spPr>
-        <p:style>
-          <a:lnRef idx="0">
-            <a:scrgbClr r="0" g="0" b="0"/>
-          </a:lnRef>
-          <a:fillRef idx="0">
-            <a:scrgbClr r="0" g="0" b="0"/>
-          </a:fillRef>
-          <a:effectRef idx="0">
-            <a:scrgbClr r="0" g="0" b="0"/>
-          </a:effectRef>
-          <a:fontRef idx="minor">
-            <a:schemeClr val="tx1"/>
-          </a:fontRef>
-        </p:style>
-      </p:cxnSp>
-      <p:cxnSp>
-        <p:nvCxnSpPr>
-          <p:cNvPr id="80" name="Straight Arrow Connector 79">
-            <a:extLst>
-              <a:ext uri="{FF2B5EF4-FFF2-40B4-BE49-F238E27FC236}">
-                <a16:creationId xmlns:a16="http://schemas.microsoft.com/office/drawing/2014/main" id="{0AD01237-CE18-7763-E2D0-8D16A2EA458C}"/>
-              </a:ext>
-            </a:extLst>
-          </p:cNvPr>
-          <p:cNvCxnSpPr>
-            <a:cxnSpLocks/>
-            <a:stCxn id="62" idx="0"/>
-          </p:cNvCxnSpPr>
-          <p:nvPr/>
-        </p:nvCxnSpPr>
-        <p:spPr>
-          <a:xfrm>
-            <a:off x="9162866" y="6153225"/>
-            <a:ext cx="38772" cy="11373"/>
-          </a:xfrm>
-          <a:prstGeom prst="straightConnector1">
-            <a:avLst/>
-          </a:prstGeom>
-          <a:ln w="9525" cap="flat" cmpd="sng" algn="ctr">
-            <a:solidFill>
-              <a:schemeClr val="dk1"/>
-            </a:solidFill>
-            <a:prstDash val="solid"/>
-            <a:round/>
-            <a:headEnd type="none" w="med" len="med"/>
-            <a:tailEnd type="arrow" w="med" len="med"/>
-          </a:ln>
-        </p:spPr>
-        <p:style>
-          <a:lnRef idx="0">
-            <a:scrgbClr r="0" g="0" b="0"/>
-          </a:lnRef>
-          <a:fillRef idx="0">
-            <a:scrgbClr r="0" g="0" b="0"/>
-          </a:fillRef>
-          <a:effectRef idx="0">
-            <a:scrgbClr r="0" g="0" b="0"/>
-          </a:effectRef>
-          <a:fontRef idx="minor">
-            <a:schemeClr val="tx1"/>
-          </a:fontRef>
-        </p:style>
-      </p:cxnSp>
-      <p:cxnSp>
-        <p:nvCxnSpPr>
-          <p:cNvPr id="83" name="Straight Arrow Connector 82">
-            <a:extLst>
-              <a:ext uri="{FF2B5EF4-FFF2-40B4-BE49-F238E27FC236}">
-                <a16:creationId xmlns:a16="http://schemas.microsoft.com/office/drawing/2014/main" id="{549304F9-295C-6EFA-767A-8C6062613CD2}"/>
-              </a:ext>
-            </a:extLst>
-          </p:cNvPr>
-          <p:cNvCxnSpPr>
-            <a:cxnSpLocks/>
-          </p:cNvCxnSpPr>
-          <p:nvPr/>
-        </p:nvCxnSpPr>
-        <p:spPr>
-          <a:xfrm flipH="1">
-            <a:off x="4966999" y="6122508"/>
-            <a:ext cx="83253" cy="52906"/>
-          </a:xfrm>
-          <a:prstGeom prst="straightConnector1">
-            <a:avLst/>
-          </a:prstGeom>
-          <a:ln w="9525" cap="flat" cmpd="sng" algn="ctr">
-            <a:solidFill>
-              <a:schemeClr val="dk1"/>
-            </a:solidFill>
-            <a:prstDash val="solid"/>
             <a:round/>
             <a:headEnd type="none" w="med" len="med"/>
             <a:tailEnd type="arrow" w="med" len="med"/>

</xml_diff>